<commit_message>
fix: resolve PPT overlaps and make prototypes interactive across all case studies
</commit_message>
<xml_diff>
--- a/assets/bybit-clearkyb-deck.pptx
+++ b/assets/bybit-clearkyb-deck.pptx
@@ -1498,7 +1498,7 @@
         <p:spPr>
           <a:xfrm>
             <a:off x="457200" y="457200"/>
-            <a:ext cx="3657600" cy="0"/>
+            <a:ext cx="3657600" cy="548640"/>
           </a:xfrm>
           <a:prstGeom prst="rect">
             <a:avLst/>
@@ -1507,7 +1507,7 @@
           <a:ln/>
         </p:spPr>
         <p:txBody>
-          <a:bodyPr wrap="square" rtlCol="0" anchor="ctr"/>
+          <a:bodyPr wrap="square" rtlCol="0" anchor="t"/>
           <a:lstStyle/>
           <a:p>
             <a:pPr indent="0" marL="0">
@@ -1554,7 +1554,7 @@
         <p:spPr>
           <a:xfrm>
             <a:off x="640080" y="1554480"/>
-            <a:ext cx="3291840" cy="0"/>
+            <a:ext cx="3291840" cy="365760"/>
           </a:xfrm>
           <a:prstGeom prst="rect">
             <a:avLst/>
@@ -1563,7 +1563,7 @@
           <a:ln/>
         </p:spPr>
         <p:txBody>
-          <a:bodyPr wrap="square" rtlCol="0" anchor="ctr"/>
+          <a:bodyPr wrap="square" rtlCol="0" anchor="t"/>
           <a:lstStyle/>
           <a:p>
             <a:pPr indent="0" marL="0">
@@ -1590,7 +1590,7 @@
         <p:spPr>
           <a:xfrm>
             <a:off x="640080" y="1920240"/>
-            <a:ext cx="3291840" cy="0"/>
+            <a:ext cx="3291840" cy="2286000"/>
           </a:xfrm>
           <a:prstGeom prst="rect">
             <a:avLst/>
@@ -1599,7 +1599,7 @@
           <a:ln/>
         </p:spPr>
         <p:txBody>
-          <a:bodyPr wrap="square" rtlCol="0" anchor="ctr"/>
+          <a:bodyPr wrap="square" rtlCol="0" anchor="t"/>
           <a:lstStyle/>
           <a:p>
             <a:pPr marL="342900" indent="-342900">
@@ -1709,7 +1709,7 @@
         <p:spPr>
           <a:xfrm>
             <a:off x="5212080" y="1554480"/>
-            <a:ext cx="3291840" cy="0"/>
+            <a:ext cx="3291840" cy="365760"/>
           </a:xfrm>
           <a:prstGeom prst="rect">
             <a:avLst/>
@@ -1718,7 +1718,7 @@
           <a:ln/>
         </p:spPr>
         <p:txBody>
-          <a:bodyPr wrap="square" rtlCol="0" anchor="ctr"/>
+          <a:bodyPr wrap="square" rtlCol="0" anchor="t"/>
           <a:lstStyle/>
           <a:p>
             <a:pPr indent="0" marL="0">
@@ -1745,7 +1745,7 @@
         <p:spPr>
           <a:xfrm>
             <a:off x="5212080" y="1920240"/>
-            <a:ext cx="3291840" cy="0"/>
+            <a:ext cx="3291840" cy="2286000"/>
           </a:xfrm>
           <a:prstGeom prst="rect">
             <a:avLst/>
@@ -1754,7 +1754,7 @@
           <a:ln/>
         </p:spPr>
         <p:txBody>
-          <a:bodyPr wrap="square" rtlCol="0" anchor="ctr"/>
+          <a:bodyPr wrap="square" rtlCol="0" anchor="t"/>
           <a:lstStyle/>
           <a:p>
             <a:pPr marL="342900" indent="-342900">
@@ -1846,7 +1846,7 @@
         <p:spPr>
           <a:xfrm>
             <a:off x="457200" y="457200"/>
-            <a:ext cx="4572000" cy="0"/>
+            <a:ext cx="4572000" cy="548640"/>
           </a:xfrm>
           <a:prstGeom prst="rect">
             <a:avLst/>
@@ -1855,7 +1855,7 @@
           <a:ln/>
         </p:spPr>
         <p:txBody>
-          <a:bodyPr wrap="square" rtlCol="0" anchor="ctr"/>
+          <a:bodyPr wrap="square" rtlCol="0" anchor="t"/>
           <a:lstStyle/>
           <a:p>
             <a:pPr indent="0" marL="0">
@@ -1882,7 +1882,7 @@
         <p:spPr>
           <a:xfrm>
             <a:off x="457200" y="1371600"/>
-            <a:ext cx="2743200" cy="0"/>
+            <a:ext cx="2743200" cy="365760"/>
           </a:xfrm>
           <a:prstGeom prst="rect">
             <a:avLst/>
@@ -1891,7 +1891,7 @@
           <a:ln/>
         </p:spPr>
         <p:txBody>
-          <a:bodyPr wrap="square" rtlCol="0" anchor="ctr"/>
+          <a:bodyPr wrap="square" rtlCol="0" anchor="t"/>
           <a:lstStyle/>
           <a:p>
             <a:pPr indent="0" marL="0">
@@ -1918,7 +1918,7 @@
         <p:spPr>
           <a:xfrm>
             <a:off x="457200" y="1828800"/>
-            <a:ext cx="2743200" cy="0"/>
+            <a:ext cx="2743200" cy="2286000"/>
           </a:xfrm>
           <a:prstGeom prst="rect">
             <a:avLst/>
@@ -1927,7 +1927,7 @@
           <a:ln/>
         </p:spPr>
         <p:txBody>
-          <a:bodyPr wrap="square" rtlCol="0" anchor="ctr"/>
+          <a:bodyPr wrap="square" rtlCol="0" anchor="t"/>
           <a:lstStyle/>
           <a:p>
             <a:pPr marL="342900" indent="-342900">
@@ -2012,7 +2012,7 @@
         <p:spPr>
           <a:xfrm>
             <a:off x="5486400" y="1371600"/>
-            <a:ext cx="2743200" cy="0"/>
+            <a:ext cx="2743200" cy="365760"/>
           </a:xfrm>
           <a:prstGeom prst="rect">
             <a:avLst/>
@@ -2021,7 +2021,7 @@
           <a:ln/>
         </p:spPr>
         <p:txBody>
-          <a:bodyPr wrap="square" rtlCol="0" anchor="ctr"/>
+          <a:bodyPr wrap="square" rtlCol="0" anchor="t"/>
           <a:lstStyle/>
           <a:p>
             <a:pPr indent="0" marL="0">
@@ -2048,7 +2048,7 @@
         <p:spPr>
           <a:xfrm>
             <a:off x="5486400" y="1828800"/>
-            <a:ext cx="2743200" cy="0"/>
+            <a:ext cx="2743200" cy="2286000"/>
           </a:xfrm>
           <a:prstGeom prst="rect">
             <a:avLst/>
@@ -2057,7 +2057,7 @@
           <a:ln/>
         </p:spPr>
         <p:txBody>
-          <a:bodyPr wrap="square" rtlCol="0" anchor="ctr"/>
+          <a:bodyPr wrap="square" rtlCol="0" anchor="t"/>
           <a:lstStyle/>
           <a:p>
             <a:pPr marL="342900" indent="-342900">
@@ -2230,7 +2230,7 @@
         <p:spPr>
           <a:xfrm>
             <a:off x="457200" y="457200"/>
-            <a:ext cx="3657600" cy="0"/>
+            <a:ext cx="3657600" cy="548640"/>
           </a:xfrm>
           <a:prstGeom prst="rect">
             <a:avLst/>
@@ -2239,7 +2239,7 @@
           <a:ln/>
         </p:spPr>
         <p:txBody>
-          <a:bodyPr wrap="square" rtlCol="0" anchor="ctr"/>
+          <a:bodyPr wrap="square" rtlCol="0" anchor="t"/>
           <a:lstStyle/>
           <a:p>
             <a:pPr indent="0" marL="0">
@@ -2679,7 +2679,7 @@
         <p:spPr>
           <a:xfrm>
             <a:off x="457200" y="457200"/>
-            <a:ext cx="3657600" cy="0"/>
+            <a:ext cx="3657600" cy="548640"/>
           </a:xfrm>
           <a:prstGeom prst="rect">
             <a:avLst/>
@@ -2688,7 +2688,7 @@
           <a:ln/>
         </p:spPr>
         <p:txBody>
-          <a:bodyPr wrap="square" rtlCol="0" anchor="ctr"/>
+          <a:bodyPr wrap="square" rtlCol="0" anchor="t"/>
           <a:lstStyle/>
           <a:p>
             <a:pPr indent="0" marL="0">

</xml_diff>